<commit_message>
Streamline Unit 2 (M5-M7), restructure exercises, update README
M5 (CLAUDE.md & Rules): Remove verbose sections (Importing External
Files, full CLAUDE.md tutorial), shorten .claude/rules/, move comparison
table to M6.

M6 (Skills & Commands): Reorder commands before skills, remove SKILL.md
format example and complex skill (moved to exercises), merge String
Substitutions + Dynamic Context, merge Priority + Permissions.

M7 (Subagents): Remove Agent Teams (Experimental) and Team Patterns,
merge MCP/Memory into defining subagents section, keep single
Infrastructure Specialist example.

Exercises: Restructure from flat configs/solutions into module-based
subfolders (m04-m15). Add SKILL-FORMAT-REFERENCE.md to M6 exercises.

README: Update to 15-module structure with correct titles and numbering.
Update slides, handouts, HTML, and outline for consistency.

Co-Authored-By: Claude Opus 4.6 <noreply@anthropic.com>
</commit_message>
<xml_diff>
--- a/slides/workshop.pptx
+++ b/slides/workshop.pptx
@@ -11077,7 +11077,7 @@
                 <a:ea typeface="Calibri" pitchFamily="34" charset="-122"/>
                 <a:cs typeface="Calibri" pitchFamily="34" charset="-120"/>
               </a:rPr>
-              <a:t>Create CLAUDE.md manually for a sample project</a:t>
+              <a:t>Run /init on a sample project to generate CLAUDE.md</a:t>
             </a:r>
             <a:endParaRPr lang="en-US" sz="1300" dirty="0"/>
           </a:p>
@@ -11182,7 +11182,7 @@
                 <a:ea typeface="Calibri" pitchFamily="34" charset="-122"/>
                 <a:cs typeface="Calibri" pitchFamily="34" charset="-120"/>
               </a:rPr>
-              <a:t>Include: build commands, code style, architecture</a:t>
+              <a:t>Customize: add deployment, gotchas, conventions</a:t>
             </a:r>
             <a:endParaRPr lang="en-US" sz="1300" dirty="0"/>
           </a:p>
@@ -11287,7 +11287,7 @@
                 <a:ea typeface="Calibri" pitchFamily="34" charset="-122"/>
                 <a:cs typeface="Calibri" pitchFamily="34" charset="-120"/>
               </a:rPr>
-              <a:t>Run /init and compare auto-generated version</a:t>
+              <a:t>Create .claude/rules/testing.md with path filter</a:t>
             </a:r>
             <a:endParaRPr lang="en-US" sz="1300" dirty="0"/>
           </a:p>
@@ -11392,7 +11392,7 @@
                 <a:ea typeface="Calibri" pitchFamily="34" charset="-122"/>
                 <a:cs typeface="Calibri" pitchFamily="34" charset="-120"/>
               </a:rPr>
-              <a:t>Create .claude/rules/testing.md with path filter</a:t>
+              <a:t>Verify: ask Claude to write code — does it follow rules?</a:t>
             </a:r>
             <a:endParaRPr lang="en-US" sz="1300" dirty="0"/>
           </a:p>
@@ -11497,7 +11497,7 @@
                 <a:ea typeface="Calibri" pitchFamily="34" charset="-122"/>
                 <a:cs typeface="Calibri" pitchFamily="34" charset="-120"/>
               </a:rPr>
-              <a:t>Test: Does Claude follow the rules?</a:t>
+              <a:t>Compare: manual vs. /init — what did it miss?</a:t>
             </a:r>
             <a:endParaRPr lang="en-US" sz="1300" dirty="0"/>
           </a:p>
@@ -12455,7 +12455,7 @@
                 <a:ea typeface="Calibri" pitchFamily="34" charset="-122"/>
                 <a:cs typeface="Calibri" pitchFamily="34" charset="-120"/>
               </a:rPr>
-              <a:t>Skills (Recommended)</a:t>
+              <a:t>Commands (Start Here)</a:t>
             </a:r>
             <a:endParaRPr lang="en-US" sz="1400" dirty="0"/>
           </a:p>
@@ -12494,7 +12494,7 @@
                 <a:ea typeface="Calibri" pitchFamily="34" charset="-122"/>
                 <a:cs typeface="Calibri" pitchFamily="34" charset="-120"/>
               </a:rPr>
-              <a:t>.claude/skills/&lt;name&gt;/SKILL.md with YAML frontmatter. Reference skills (auto-loaded knowledge) or Action skills (invocable /name)</a:t>
+              <a:t>.claude/commands/&lt;name&gt;.md — single Markdown file, minimal setup. Start here for quick prompt shortcuts.</a:t>
             </a:r>
             <a:endParaRPr lang="en-US" sz="1100" dirty="0"/>
           </a:p>
@@ -12733,7 +12733,7 @@
                 <a:ea typeface="Calibri" pitchFamily="34" charset="-122"/>
                 <a:cs typeface="Calibri" pitchFamily="34" charset="-120"/>
               </a:rPr>
-              <a:t>Commands (Simple)</a:t>
+              <a:t>Skills (Complex)</a:t>
             </a:r>
             <a:endParaRPr lang="en-US" sz="1400" dirty="0"/>
           </a:p>
@@ -12772,7 +12772,7 @@
                 <a:ea typeface="Calibri" pitchFamily="34" charset="-122"/>
                 <a:cs typeface="Calibri" pitchFamily="34" charset="-120"/>
               </a:rPr>
-              <a:t>.claude/commands/&lt;name&gt;.md — Markdown with $ARGUMENTS. Quick alternative for simple prompts.</a:t>
+              <a:t>.claude/skills/&lt;name&gt;/SKILL.md with YAML frontmatter. Reference (auto-loaded) or Action (invocable /name).</a:t>
             </a:r>
             <a:endParaRPr lang="en-US" sz="1100" dirty="0"/>
           </a:p>
@@ -14546,7 +14546,7 @@
                 <a:ea typeface="Arial Black" pitchFamily="34" charset="-122"/>
                 <a:cs typeface="Arial Black" pitchFamily="34" charset="-120"/>
               </a:rPr>
-              <a:t>Subagents &amp; Agent Teams</a:t>
+              <a:t>Subagents</a:t>
             </a:r>
             <a:endParaRPr lang="en-US" sz="2800" dirty="0"/>
           </a:p>
@@ -15141,7 +15141,7 @@
                 <a:ea typeface="Calibri" pitchFamily="34" charset="-122"/>
                 <a:cs typeface="Calibri" pitchFamily="34" charset="-120"/>
               </a:rPr>
-              <a:t>Agent Teams (Experimental)</a:t>
+              <a:t>Tool Control &amp; MCP</a:t>
             </a:r>
             <a:endParaRPr lang="en-US" sz="1400" dirty="0"/>
           </a:p>
@@ -15180,7 +15180,7 @@
                 <a:ea typeface="Calibri" pitchFamily="34" charset="-122"/>
                 <a:cs typeface="Calibri" pitchFamily="34" charset="-120"/>
               </a:rPr>
-              <a:t>Multiple independent sessions coordinating via shared task list + peer-to-peer messaging</a:t>
+              <a:t>Allowlist/denylist, wildcards (Bash(git *)), inline MCP servers, memory scoping</a:t>
             </a:r>
             <a:endParaRPr lang="en-US" sz="1100" dirty="0"/>
           </a:p>
@@ -16253,7 +16253,7 @@
                           <a:ea typeface="Calibri" pitchFamily="34" charset="-122"/>
                           <a:cs typeface="Calibri" pitchFamily="34" charset="-120"/>
                         </a:rPr>
-                        <a:t>Agent Teams</a:t>
+                        <a:t>Tool Control &amp; MCP</a:t>
                       </a:r>
                       <a:endParaRPr lang="en-US" sz="1000" dirty="0">
                         <a:latin typeface="Calibri" charset="0"/>
@@ -16522,7 +16522,7 @@
                 <a:ea typeface="Calibri" pitchFamily="34" charset="-122"/>
                 <a:cs typeface="Calibri" pitchFamily="34" charset="-120"/>
               </a:rPr>
-              <a:t>Agent Teams: CLAUDE_CODE_EXPERIMENTAL_AGENT_TEAMS=1  ·  Shift+Down to cycle teammates</a:t>
+              <a:t>Allowlist/denylist, wildcards (Bash(git *)), inline MCP servers, memory scoping</a:t>
             </a:r>
             <a:endParaRPr lang="en-US" sz="1100" dirty="0"/>
           </a:p>

</xml_diff>

<commit_message>
Sync all artifacts with revised module content
Update outline, HTML, handouts, slides, and exercises to match
the streamlined modules M8-M15:
- Fix durations: M9 (25→15), M10 (30→15), M12 (15→10), M15 (25→30)
- Remove references to cut content: HTTP hooks, async hooks,
  worktrees, dispatch, agent SDK, messages API, teleported sessions
- Update M8 exercise from GitHub MCP to local filesystem MCP
- Update M9 exercise from prettier hook to security hook
- Fix M10 exercise label (was "Module 9")
- Update HTML module cards with correct descriptions and times
- Update feature coverage matrix in outline

Co-Authored-By: Claude Opus 4.6 <noreply@anthropic.com>
</commit_message>
<xml_diff>
--- a/slides/workshop.pptx
+++ b/slides/workshop.pptx
@@ -17467,7 +17467,7 @@
                 <a:ea typeface="Calibri" pitchFamily="34" charset="-122"/>
                 <a:cs typeface="Calibri" pitchFamily="34" charset="-120"/>
               </a:rPr>
-              <a:t>M8 MCP (35 min)  ·  M9 Hooks (25 min)  ·  M10 CLI &amp; Headless (30 min)</a:t>
+              <a:t>M8 MCP (35 min)  ·  M9 Hooks (15 min)  ·  M10 CLI &amp; Headless (15 min)</a:t>
             </a:r>
             <a:endParaRPr lang="en-US" sz="1300" dirty="0"/>
           </a:p>
@@ -17863,7 +17863,7 @@
                 <a:ea typeface="Calibri" pitchFamily="34" charset="-122"/>
                 <a:cs typeface="Calibri" pitchFamily="34" charset="-120"/>
               </a:rPr>
-              <a:t>Model Context Protocol — open standard for connecting AI to external tools and data sources</a:t>
+              <a:t>Open standard for connecting AI to external tools. Auto-discovered at session start, plugin-compatible</a:t>
             </a:r>
             <a:endParaRPr lang="en-US" sz="1100" dirty="0"/>
           </a:p>
@@ -18002,7 +18002,7 @@
                 <a:ea typeface="Calibri" pitchFamily="34" charset="-122"/>
                 <a:cs typeface="Calibri" pitchFamily="34" charset="-120"/>
               </a:rPr>
-              <a:t>HTTP (recommended for cloud) · stdio (local processes) · SSE (deprecated)</a:t>
+              <a:t>stdio (local dev) · HTTP (cloud/shared). Windows: wrap with cmd /c. Rule: local → stdio, cloud → HTTP</a:t>
             </a:r>
             <a:endParaRPr lang="en-US" sz="1100" dirty="0"/>
           </a:p>
@@ -18102,7 +18102,7 @@
                 <a:ea typeface="Calibri" pitchFamily="34" charset="-122"/>
                 <a:cs typeface="Calibri" pitchFamily="34" charset="-120"/>
               </a:rPr>
-              <a:t>Three Scopes</a:t>
+              <a:t>Installing &amp; Management</a:t>
             </a:r>
             <a:endParaRPr lang="en-US" sz="1400" dirty="0"/>
           </a:p>
@@ -18141,7 +18141,7 @@
                 <a:ea typeface="Calibri" pitchFamily="34" charset="-122"/>
                 <a:cs typeface="Calibri" pitchFamily="34" charset="-120"/>
               </a:rPr>
-              <a:t>Local (~/.claude.json per project) &gt; Project (.mcp.json, committed) &gt; User (~/.claude.json global)</a:t>
+              <a:t>claude mcp add/list/get/remove. /mcp for health check. MCP_DEBUG=1 for troubleshooting</a:t>
             </a:r>
             <a:endParaRPr lang="en-US" sz="1100" dirty="0"/>
           </a:p>
@@ -18241,7 +18241,7 @@
                 <a:ea typeface="Calibri" pitchFamily="34" charset="-122"/>
                 <a:cs typeface="Calibri" pitchFamily="34" charset="-120"/>
               </a:rPr>
-              <a:t>Use Cases</a:t>
+              <a:t>Scope</a:t>
             </a:r>
             <a:endParaRPr lang="en-US" sz="1400" dirty="0"/>
           </a:p>
@@ -18280,7 +18280,7 @@
                 <a:ea typeface="Calibri" pitchFamily="34" charset="-122"/>
                 <a:cs typeface="Calibri" pitchFamily="34" charset="-120"/>
               </a:rPr>
-              <a:t>GitHub, Jira, databases, Slack, Figma, monitoring (Sentry), filesystem — 100+ servers available</a:t>
+              <a:t>Local (per-project) · Project (.mcp.json, committed) · User (global). --scope flag controls where saved</a:t>
             </a:r>
             <a:endParaRPr lang="en-US" sz="1100" dirty="0"/>
           </a:p>
@@ -18393,7 +18393,7 @@
                 <a:ea typeface="Arial Black" pitchFamily="34" charset="-122"/>
                 <a:cs typeface="Arial Black" pitchFamily="34" charset="-120"/>
               </a:rPr>
-              <a:t>MCP Installation &amp; Configuration</a:t>
+              <a:t>MCP Installation &amp; Management</a:t>
             </a:r>
             <a:endParaRPr lang="en-US" sz="2400" dirty="0"/>
           </a:p>
@@ -19613,7 +19613,7 @@
                 <a:ea typeface="Calibri" pitchFamily="34" charset="-122"/>
                 <a:cs typeface="Calibri" pitchFamily="34" charset="-120"/>
               </a:rPr>
-              <a:t>Important: All flags must come BEFORE server name. -- separates Claude flags from server command.</a:t>
+              <a:t>Flags BEFORE server name. -- separates Claude from server args. Debug: MCP_DEBUG=1 claude or /mcp in-session</a:t>
             </a:r>
             <a:endParaRPr lang="en-US" sz="1100" dirty="0"/>
           </a:p>
@@ -21251,7 +21251,7 @@
                 <a:ea typeface="Arial Black" pitchFamily="34" charset="-122"/>
                 <a:cs typeface="Arial Black" pitchFamily="34" charset="-120"/>
               </a:rPr>
-              <a:t>Hooks: Guaranteeing Determinism</a:t>
+              <a:t>Hooks: Deterministic Guardrails</a:t>
             </a:r>
             <a:endParaRPr lang="en-US" sz="2800" dirty="0"/>
           </a:p>
@@ -21329,7 +21329,7 @@
                 <a:ea typeface="Calibri" pitchFamily="34" charset="-122"/>
                 <a:cs typeface="Calibri" pitchFamily="34" charset="-120"/>
               </a:rPr>
-              <a:t>25 min</a:t>
+              <a:t>15 min</a:t>
             </a:r>
             <a:endParaRPr lang="en-US" sz="1100" dirty="0"/>
           </a:p>
@@ -21607,7 +21607,7 @@
                 <a:ea typeface="Calibri" pitchFamily="34" charset="-122"/>
                 <a:cs typeface="Calibri" pitchFamily="34" charset="-120"/>
               </a:rPr>
-              <a:t>Command hooks (shell scripts) · HTTP hooks (POST to URL) · Async hooks (fire-and-forget)</a:t>
+              <a:t>Command hooks (shell scripts)</a:t>
             </a:r>
             <a:endParaRPr lang="en-US" sz="1100" dirty="0"/>
           </a:p>
@@ -25159,7 +25159,7 @@
                 <a:ea typeface="Calibri" pitchFamily="34" charset="-122"/>
                 <a:cs typeface="Calibri" pitchFamily="34" charset="-120"/>
               </a:rPr>
-              <a:t>30 min</a:t>
+              <a:t>15 min</a:t>
             </a:r>
             <a:endParaRPr lang="en-US" sz="1100" dirty="0"/>
           </a:p>
@@ -25640,84 +25640,6 @@
           <a:lstStyle/>
           <a:p>
             <a:endParaRPr lang="de-DE"/>
-          </a:p>
-        </p:txBody>
-      </p:sp>
-      <p:sp>
-        <p:nvSpPr>
-          <p:cNvPr id="20" name="Text 18"/>
-          <p:cNvSpPr/>
-          <p:nvPr/>
-        </p:nvSpPr>
-        <p:spPr>
-          <a:xfrm>
-            <a:off x="1005840" y="3694176"/>
-            <a:ext cx="2194560" cy="274320"/>
-          </a:xfrm>
-          <a:prstGeom prst="rect">
-            <a:avLst/>
-          </a:prstGeom>
-          <a:noFill/>
-          <a:ln/>
-        </p:spPr>
-        <p:txBody>
-          <a:bodyPr wrap="square" rtlCol="0" anchor="ctr"/>
-          <a:lstStyle/>
-          <a:p>
-            <a:pPr marL="0" indent="0">
-              <a:buNone/>
-            </a:pPr>
-            <a:r>
-              <a:rPr lang="en-US" sz="1400" b="1" dirty="0">
-                <a:solidFill>
-                  <a:srgbClr val="151D47"/>
-                </a:solidFill>
-                <a:latin typeface="Calibri" pitchFamily="34" charset="0"/>
-                <a:ea typeface="Calibri" pitchFamily="34" charset="-122"/>
-                <a:cs typeface="Calibri" pitchFamily="34" charset="-120"/>
-              </a:rPr>
-              <a:t>Worktrees</a:t>
-            </a:r>
-            <a:endParaRPr lang="en-US" sz="1400" dirty="0"/>
-          </a:p>
-        </p:txBody>
-      </p:sp>
-      <p:sp>
-        <p:nvSpPr>
-          <p:cNvPr id="21" name="Text 19"/>
-          <p:cNvSpPr/>
-          <p:nvPr/>
-        </p:nvSpPr>
-        <p:spPr>
-          <a:xfrm>
-            <a:off x="1005840" y="3941064"/>
-            <a:ext cx="7132320" cy="438912"/>
-          </a:xfrm>
-          <a:prstGeom prst="rect">
-            <a:avLst/>
-          </a:prstGeom>
-          <a:noFill/>
-          <a:ln/>
-        </p:spPr>
-        <p:txBody>
-          <a:bodyPr wrap="square" rtlCol="0" anchor="ctr"/>
-          <a:lstStyle/>
-          <a:p>
-            <a:pPr marL="0" indent="0">
-              <a:buNone/>
-            </a:pPr>
-            <a:r>
-              <a:rPr lang="en-US" sz="1100" dirty="0">
-                <a:solidFill>
-                  <a:srgbClr val="64748B"/>
-                </a:solidFill>
-                <a:latin typeface="Calibri" pitchFamily="34" charset="0"/>
-                <a:ea typeface="Calibri" pitchFamily="34" charset="-122"/>
-                <a:cs typeface="Calibri" pitchFamily="34" charset="-120"/>
-              </a:rPr>
-              <a:t>claude --worktree for isolated parallel sessions · --tmux for tmux integration</a:t>
-            </a:r>
-            <a:endParaRPr lang="en-US" sz="1100" dirty="0"/>
           </a:p>
         </p:txBody>
       </p:sp>
@@ -25828,7 +25750,7 @@
                 <a:ea typeface="Arial Black" pitchFamily="34" charset="-122"/>
                 <a:cs typeface="Arial Black" pitchFamily="34" charset="-120"/>
               </a:rPr>
-              <a:t>CI/CD · Dispatch · Agent SDK</a:t>
+              <a:t>CI/CD Integration</a:t>
             </a:r>
             <a:endParaRPr lang="en-US" sz="2400" dirty="0"/>
           </a:p>
@@ -26125,101 +26047,6 @@
       </p:sp>
       <p:sp>
         <p:nvSpPr>
-          <p:cNvPr id="9" name="Text 7"/>
-          <p:cNvSpPr/>
-          <p:nvPr/>
-        </p:nvSpPr>
-        <p:spPr>
-          <a:xfrm>
-            <a:off x="5669280" y="960120"/>
-            <a:ext cx="2560320" cy="274320"/>
-          </a:xfrm>
-          <a:prstGeom prst="rect">
-            <a:avLst/>
-          </a:prstGeom>
-          <a:noFill/>
-          <a:ln/>
-        </p:spPr>
-        <p:txBody>
-          <a:bodyPr wrap="square" rtlCol="0" anchor="ctr"/>
-          <a:lstStyle/>
-          <a:p>
-            <a:pPr marL="0" indent="0">
-              <a:buNone/>
-            </a:pPr>
-            <a:r>
-              <a:rPr lang="en-US" sz="1300" b="1" dirty="0">
-                <a:solidFill>
-                  <a:srgbClr val="151D47"/>
-                </a:solidFill>
-                <a:latin typeface="Calibri" pitchFamily="34" charset="0"/>
-                <a:ea typeface="Calibri" pitchFamily="34" charset="-122"/>
-                <a:cs typeface="Calibri" pitchFamily="34" charset="-120"/>
-              </a:rPr>
-              <a:t>Dispatch</a:t>
-            </a:r>
-            <a:endParaRPr lang="en-US" sz="1300" dirty="0"/>
-          </a:p>
-        </p:txBody>
-      </p:sp>
-      <p:sp>
-        <p:nvSpPr>
-          <p:cNvPr id="10" name="Text 8"/>
-          <p:cNvSpPr/>
-          <p:nvPr/>
-        </p:nvSpPr>
-        <p:spPr>
-          <a:xfrm>
-            <a:off x="5669280" y="1261872"/>
-            <a:ext cx="2560320" cy="365760"/>
-          </a:xfrm>
-          <a:prstGeom prst="rect">
-            <a:avLst/>
-          </a:prstGeom>
-          <a:noFill/>
-          <a:ln/>
-        </p:spPr>
-        <p:txBody>
-          <a:bodyPr wrap="square" rtlCol="0" anchor="ctr"/>
-          <a:lstStyle/>
-          <a:p>
-            <a:pPr marL="0" indent="0">
-              <a:buNone/>
-            </a:pPr>
-            <a:r>
-              <a:rPr lang="en-US" sz="1000" dirty="0">
-                <a:solidFill>
-                  <a:srgbClr val="64748B"/>
-                </a:solidFill>
-                <a:latin typeface="Calibri" pitchFamily="34" charset="0"/>
-                <a:ea typeface="Calibri" pitchFamily="34" charset="-122"/>
-                <a:cs typeface="Calibri" pitchFamily="34" charset="-120"/>
-              </a:rPr>
-              <a:t>Trigger Claude Code tasks</a:t>
-            </a:r>
-            <a:endParaRPr lang="en-US" sz="1000" dirty="0"/>
-          </a:p>
-          <a:p>
-            <a:pPr marL="0" indent="0">
-              <a:buNone/>
-            </a:pPr>
-            <a:r>
-              <a:rPr lang="en-US" sz="1000" dirty="0">
-                <a:solidFill>
-                  <a:srgbClr val="64748B"/>
-                </a:solidFill>
-                <a:latin typeface="Calibri" pitchFamily="34" charset="0"/>
-                <a:ea typeface="Calibri" pitchFamily="34" charset="-122"/>
-                <a:cs typeface="Calibri" pitchFamily="34" charset="-120"/>
-              </a:rPr>
-              <a:t>programmatically via REST API</a:t>
-            </a:r>
-            <a:endParaRPr lang="en-US" sz="1000" dirty="0"/>
-          </a:p>
-        </p:txBody>
-      </p:sp>
-      <p:sp>
-        <p:nvSpPr>
           <p:cNvPr id="11" name="Shape 9"/>
           <p:cNvSpPr/>
           <p:nvPr/>
@@ -26281,101 +26108,6 @@
       </p:sp>
       <p:sp>
         <p:nvSpPr>
-          <p:cNvPr id="13" name="Text 11"/>
-          <p:cNvSpPr/>
-          <p:nvPr/>
-        </p:nvSpPr>
-        <p:spPr>
-          <a:xfrm>
-            <a:off x="5669280" y="1874520"/>
-            <a:ext cx="2560320" cy="274320"/>
-          </a:xfrm>
-          <a:prstGeom prst="rect">
-            <a:avLst/>
-          </a:prstGeom>
-          <a:noFill/>
-          <a:ln/>
-        </p:spPr>
-        <p:txBody>
-          <a:bodyPr wrap="square" rtlCol="0" anchor="ctr"/>
-          <a:lstStyle/>
-          <a:p>
-            <a:pPr marL="0" indent="0">
-              <a:buNone/>
-            </a:pPr>
-            <a:r>
-              <a:rPr lang="en-US" sz="1300" b="1" dirty="0">
-                <a:solidFill>
-                  <a:srgbClr val="151D47"/>
-                </a:solidFill>
-                <a:latin typeface="Calibri" pitchFamily="34" charset="0"/>
-                <a:ea typeface="Calibri" pitchFamily="34" charset="-122"/>
-                <a:cs typeface="Calibri" pitchFamily="34" charset="-120"/>
-              </a:rPr>
-              <a:t>Scheduled Tasks</a:t>
-            </a:r>
-            <a:endParaRPr lang="en-US" sz="1300" dirty="0"/>
-          </a:p>
-        </p:txBody>
-      </p:sp>
-      <p:sp>
-        <p:nvSpPr>
-          <p:cNvPr id="14" name="Text 12"/>
-          <p:cNvSpPr/>
-          <p:nvPr/>
-        </p:nvSpPr>
-        <p:spPr>
-          <a:xfrm>
-            <a:off x="5669280" y="2176272"/>
-            <a:ext cx="2560320" cy="365760"/>
-          </a:xfrm>
-          <a:prstGeom prst="rect">
-            <a:avLst/>
-          </a:prstGeom>
-          <a:noFill/>
-          <a:ln/>
-        </p:spPr>
-        <p:txBody>
-          <a:bodyPr wrap="square" rtlCol="0" anchor="ctr"/>
-          <a:lstStyle/>
-          <a:p>
-            <a:pPr marL="0" indent="0">
-              <a:buNone/>
-            </a:pPr>
-            <a:r>
-              <a:rPr lang="en-US" sz="1000" dirty="0">
-                <a:solidFill>
-                  <a:srgbClr val="64748B"/>
-                </a:solidFill>
-                <a:latin typeface="Calibri" pitchFamily="34" charset="0"/>
-                <a:ea typeface="Calibri" pitchFamily="34" charset="-122"/>
-                <a:cs typeface="Calibri" pitchFamily="34" charset="-120"/>
-              </a:rPr>
-              <a:t>Recurring jobs on Anthropic</a:t>
-            </a:r>
-            <a:endParaRPr lang="en-US" sz="1000" dirty="0"/>
-          </a:p>
-          <a:p>
-            <a:pPr marL="0" indent="0">
-              <a:buNone/>
-            </a:pPr>
-            <a:r>
-              <a:rPr lang="en-US" sz="1000" dirty="0">
-                <a:solidFill>
-                  <a:srgbClr val="64748B"/>
-                </a:solidFill>
-                <a:latin typeface="Calibri" pitchFamily="34" charset="0"/>
-                <a:ea typeface="Calibri" pitchFamily="34" charset="-122"/>
-                <a:cs typeface="Calibri" pitchFamily="34" charset="-120"/>
-              </a:rPr>
-              <a:t>cloud infrastructure</a:t>
-            </a:r>
-            <a:endParaRPr lang="en-US" sz="1000" dirty="0"/>
-          </a:p>
-        </p:txBody>
-      </p:sp>
-      <p:sp>
-        <p:nvSpPr>
           <p:cNvPr id="15" name="Shape 13"/>
           <p:cNvSpPr/>
           <p:nvPr/>
@@ -26432,101 +26164,6 @@
           <a:lstStyle/>
           <a:p>
             <a:endParaRPr lang="de-DE"/>
-          </a:p>
-        </p:txBody>
-      </p:sp>
-      <p:sp>
-        <p:nvSpPr>
-          <p:cNvPr id="17" name="Text 15"/>
-          <p:cNvSpPr/>
-          <p:nvPr/>
-        </p:nvSpPr>
-        <p:spPr>
-          <a:xfrm>
-            <a:off x="5669280" y="2788920"/>
-            <a:ext cx="2560320" cy="274320"/>
-          </a:xfrm>
-          <a:prstGeom prst="rect">
-            <a:avLst/>
-          </a:prstGeom>
-          <a:noFill/>
-          <a:ln/>
-        </p:spPr>
-        <p:txBody>
-          <a:bodyPr wrap="square" rtlCol="0" anchor="ctr"/>
-          <a:lstStyle/>
-          <a:p>
-            <a:pPr marL="0" indent="0">
-              <a:buNone/>
-            </a:pPr>
-            <a:r>
-              <a:rPr lang="en-US" sz="1300" b="1" dirty="0">
-                <a:solidFill>
-                  <a:srgbClr val="151D47"/>
-                </a:solidFill>
-                <a:latin typeface="Calibri" pitchFamily="34" charset="0"/>
-                <a:ea typeface="Calibri" pitchFamily="34" charset="-122"/>
-                <a:cs typeface="Calibri" pitchFamily="34" charset="-120"/>
-              </a:rPr>
-              <a:t>Agent SDK</a:t>
-            </a:r>
-            <a:endParaRPr lang="en-US" sz="1300" dirty="0"/>
-          </a:p>
-        </p:txBody>
-      </p:sp>
-      <p:sp>
-        <p:nvSpPr>
-          <p:cNvPr id="18" name="Text 16"/>
-          <p:cNvSpPr/>
-          <p:nvPr/>
-        </p:nvSpPr>
-        <p:spPr>
-          <a:xfrm>
-            <a:off x="5669280" y="3090672"/>
-            <a:ext cx="2560320" cy="365760"/>
-          </a:xfrm>
-          <a:prstGeom prst="rect">
-            <a:avLst/>
-          </a:prstGeom>
-          <a:noFill/>
-          <a:ln/>
-        </p:spPr>
-        <p:txBody>
-          <a:bodyPr wrap="square" rtlCol="0" anchor="ctr"/>
-          <a:lstStyle/>
-          <a:p>
-            <a:pPr marL="0" indent="0">
-              <a:buNone/>
-            </a:pPr>
-            <a:r>
-              <a:rPr lang="en-US" sz="1000" dirty="0">
-                <a:solidFill>
-                  <a:srgbClr val="64748B"/>
-                </a:solidFill>
-                <a:latin typeface="Calibri" pitchFamily="34" charset="0"/>
-                <a:ea typeface="Calibri" pitchFamily="34" charset="-122"/>
-                <a:cs typeface="Calibri" pitchFamily="34" charset="-120"/>
-              </a:rPr>
-              <a:t>@anthropic-ai/claude-agent-sdk</a:t>
-            </a:r>
-            <a:endParaRPr lang="en-US" sz="1000" dirty="0"/>
-          </a:p>
-          <a:p>
-            <a:pPr marL="0" indent="0">
-              <a:buNone/>
-            </a:pPr>
-            <a:r>
-              <a:rPr lang="en-US" sz="1000" dirty="0">
-                <a:solidFill>
-                  <a:srgbClr val="64748B"/>
-                </a:solidFill>
-                <a:latin typeface="Calibri" pitchFamily="34" charset="0"/>
-                <a:ea typeface="Calibri" pitchFamily="34" charset="-122"/>
-                <a:cs typeface="Calibri" pitchFamily="34" charset="-120"/>
-              </a:rPr>
-              <a:t>Node.js library for custom agents</a:t>
-            </a:r>
-            <a:endParaRPr lang="en-US" sz="1000" dirty="0"/>
           </a:p>
         </p:txBody>
       </p:sp>
@@ -27613,7 +27250,7 @@
                 <a:ea typeface="Calibri" pitchFamily="34" charset="-122"/>
                 <a:cs typeface="Calibri" pitchFamily="34" charset="-120"/>
               </a:rPr>
-              <a:t>M11 Plugins (10) · M12 Remote (15) · M13 Settings (10) · M14 Best Practices (15) · M15 Capstone (25)</a:t>
+              <a:t>M11 Plugins (10) · M12 Remote (10) · M13 Settings (10) · M14 Best Practices (15) · M15 Capstone (30)</a:t>
             </a:r>
             <a:endParaRPr lang="en-US" sz="1300" dirty="0"/>
           </a:p>
@@ -29548,7 +29185,7 @@
                 <a:ea typeface="Calibri" pitchFamily="34" charset="-122"/>
                 <a:cs typeface="Calibri" pitchFamily="34" charset="-120"/>
               </a:rPr>
-              <a:t>15 min</a:t>
+              <a:t>10 min</a:t>
             </a:r>
             <a:endParaRPr lang="en-US" sz="1100" dirty="0"/>
           </a:p>
@@ -29756,84 +29393,6 @@
       </p:sp>
       <p:sp>
         <p:nvSpPr>
-          <p:cNvPr id="12" name="Text 10"/>
-          <p:cNvSpPr/>
-          <p:nvPr/>
-        </p:nvSpPr>
-        <p:spPr>
-          <a:xfrm>
-            <a:off x="1005840" y="1993392"/>
-            <a:ext cx="2194560" cy="274320"/>
-          </a:xfrm>
-          <a:prstGeom prst="rect">
-            <a:avLst/>
-          </a:prstGeom>
-          <a:noFill/>
-          <a:ln/>
-        </p:spPr>
-        <p:txBody>
-          <a:bodyPr wrap="square" rtlCol="0" anchor="ctr"/>
-          <a:lstStyle/>
-          <a:p>
-            <a:pPr marL="0" indent="0">
-              <a:buNone/>
-            </a:pPr>
-            <a:r>
-              <a:rPr lang="en-US" sz="1400" b="1" dirty="0">
-                <a:solidFill>
-                  <a:srgbClr val="151D47"/>
-                </a:solidFill>
-                <a:latin typeface="Calibri" pitchFamily="34" charset="0"/>
-                <a:ea typeface="Calibri" pitchFamily="34" charset="-122"/>
-                <a:cs typeface="Calibri" pitchFamily="34" charset="-120"/>
-              </a:rPr>
-              <a:t>Handoffs</a:t>
-            </a:r>
-            <a:endParaRPr lang="en-US" sz="1400" dirty="0"/>
-          </a:p>
-        </p:txBody>
-      </p:sp>
-      <p:sp>
-        <p:nvSpPr>
-          <p:cNvPr id="13" name="Text 11"/>
-          <p:cNvSpPr/>
-          <p:nvPr/>
-        </p:nvSpPr>
-        <p:spPr>
-          <a:xfrm>
-            <a:off x="1005840" y="2240280"/>
-            <a:ext cx="7132320" cy="438912"/>
-          </a:xfrm>
-          <a:prstGeom prst="rect">
-            <a:avLst/>
-          </a:prstGeom>
-          <a:noFill/>
-          <a:ln/>
-        </p:spPr>
-        <p:txBody>
-          <a:bodyPr wrap="square" rtlCol="0" anchor="ctr"/>
-          <a:lstStyle/>
-          <a:p>
-            <a:pPr marL="0" indent="0">
-              <a:buNone/>
-            </a:pPr>
-            <a:r>
-              <a:rPr lang="en-US" sz="1100" dirty="0">
-                <a:solidFill>
-                  <a:srgbClr val="64748B"/>
-                </a:solidFill>
-                <a:latin typeface="Calibri" pitchFamily="34" charset="0"/>
-                <a:ea typeface="Calibri" pitchFamily="34" charset="-122"/>
-                <a:cs typeface="Calibri" pitchFamily="34" charset="-120"/>
-              </a:rPr>
-              <a:t>Web → Terminal: --teleport · Terminal → Web: --remote · Ultraplan: cloud-based planning</a:t>
-            </a:r>
-            <a:endParaRPr lang="en-US" sz="1100" dirty="0"/>
-          </a:p>
-        </p:txBody>
-      </p:sp>
-      <p:sp>
-        <p:nvSpPr>
           <p:cNvPr id="14" name="Shape 12"/>
           <p:cNvSpPr/>
           <p:nvPr/>
@@ -29890,84 +29449,6 @@
           <a:lstStyle/>
           <a:p>
             <a:endParaRPr lang="de-DE"/>
-          </a:p>
-        </p:txBody>
-      </p:sp>
-      <p:sp>
-        <p:nvSpPr>
-          <p:cNvPr id="16" name="Text 14"/>
-          <p:cNvSpPr/>
-          <p:nvPr/>
-        </p:nvSpPr>
-        <p:spPr>
-          <a:xfrm>
-            <a:off x="1005840" y="2843784"/>
-            <a:ext cx="2194560" cy="274320"/>
-          </a:xfrm>
-          <a:prstGeom prst="rect">
-            <a:avLst/>
-          </a:prstGeom>
-          <a:noFill/>
-          <a:ln/>
-        </p:spPr>
-        <p:txBody>
-          <a:bodyPr wrap="square" rtlCol="0" anchor="ctr"/>
-          <a:lstStyle/>
-          <a:p>
-            <a:pPr marL="0" indent="0">
-              <a:buNone/>
-            </a:pPr>
-            <a:r>
-              <a:rPr lang="en-US" sz="1400" b="1" dirty="0">
-                <a:solidFill>
-                  <a:srgbClr val="151D47"/>
-                </a:solidFill>
-                <a:latin typeface="Calibri" pitchFamily="34" charset="0"/>
-                <a:ea typeface="Calibri" pitchFamily="34" charset="-122"/>
-                <a:cs typeface="Calibri" pitchFamily="34" charset="-120"/>
-              </a:rPr>
-              <a:t>Remote Control</a:t>
-            </a:r>
-            <a:endParaRPr lang="en-US" sz="1400" dirty="0"/>
-          </a:p>
-        </p:txBody>
-      </p:sp>
-      <p:sp>
-        <p:nvSpPr>
-          <p:cNvPr id="17" name="Text 15"/>
-          <p:cNvSpPr/>
-          <p:nvPr/>
-        </p:nvSpPr>
-        <p:spPr>
-          <a:xfrm>
-            <a:off x="1005840" y="3090672"/>
-            <a:ext cx="7132320" cy="438912"/>
-          </a:xfrm>
-          <a:prstGeom prst="rect">
-            <a:avLst/>
-          </a:prstGeom>
-          <a:noFill/>
-          <a:ln/>
-        </p:spPr>
-        <p:txBody>
-          <a:bodyPr wrap="square" rtlCol="0" anchor="ctr"/>
-          <a:lstStyle/>
-          <a:p>
-            <a:pPr marL="0" indent="0">
-              <a:buNone/>
-            </a:pPr>
-            <a:r>
-              <a:rPr lang="en-US" sz="1100" dirty="0">
-                <a:solidFill>
-                  <a:srgbClr val="64748B"/>
-                </a:solidFill>
-                <a:latin typeface="Calibri" pitchFamily="34" charset="0"/>
-                <a:ea typeface="Calibri" pitchFamily="34" charset="-122"/>
-                <a:cs typeface="Calibri" pitchFamily="34" charset="-120"/>
-              </a:rPr>
-              <a:t>Share sessions, pair-programming. --remote-control-session-name-prefix</a:t>
-            </a:r>
-            <a:endParaRPr lang="en-US" sz="1100" dirty="0"/>
           </a:p>
         </p:txBody>
       </p:sp>
@@ -46917,7 +46398,7 @@
             </a:pPr>
             <a:r>
               <a:rPr sz="900"/>
-              <a:t>Code examples in Module 9 — Messages API Essentials</a:t>
+              <a:t>M1 — Advanced Features</a:t>
             </a:r>
           </a:p>
         </p:txBody>

</xml_diff>